<commit_message>
refactor(aula8): renomear obstáculo para plataforma móvel (AnimatableBody2D)
Co-authored-by: Cursor <cursoragent@cursor.com>
</commit_message>
<xml_diff>
--- a/assets/docs/aulas/aula08_quantic_foundry_slides.pptx
+++ b/assets/docs/aulas/aula08_quantic_foundry_slides.pptx
@@ -2882,7 +2882,7 @@
                 <a:cs typeface="Georgia"/>
                 <a:ea typeface="Georgia"/>
               </a:rPr>
-              <a:t>Obstáculos que se movem.</a:t>
+              <a:t>Plataformas móveis.</a:t>
             </a:r>
           </a:p>
           <a:p>
@@ -3569,7 +3569,7 @@
                 <a:cs typeface="Georgia"/>
                 <a:ea typeface="Georgia"/>
               </a:rPr>
-              <a:t>Obstáculo móvel (vai-e-volta).</a:t>
+              <a:t>Plataforma móvel (vai-e-volta).</a:t>
             </a:r>
           </a:p>
           <a:p>

</xml_diff>